<commit_message>
Lesson sd-10-009: explain the message path from the Linux kernel sources, with the figure, metadata and deck to match
Co-Authored-By: Claude Sonnet 5.5 <noreply@anthropic.com>
Claude-Session: https://claude.ai/code/session_01Y9NYFwg4CcDYEWi1zr53gi
</commit_message>
<xml_diff>
--- a/system-design-101/vi/lessons/sd-10-009/slides/sd-10-009.pptx
+++ b/system-design-101/vi/lessons/sd-10-009/slides/sd-10-009.pptx
@@ -4964,10 +4964,10 @@
                 <a:ea typeface="Be Vietnam Pro" pitchFamily="34" charset="-122"/>
                 <a:cs typeface="Be Vietnam Pro" pitchFamily="34" charset="-120"/>
               </a:rPr>
-              <a:t> 2026-10-18.</a:t>
-            </a:r>
-            <a:r>
-              <a:rPr lang="en-US" sz="1950" dirty="0" spc="0" kern="0">
+              <a:t> 2026-10-19.</a:t>
+            </a:r>
+            <a:r>
+              <a:rPr lang="en-US" sz="1950" dirty="0" spc="1" kern="0">
                 <a:solidFill>
                   <a:srgbClr val="9AA0B5"/>
                 </a:solidFill>
@@ -4989,7 +4989,7 @@
               <a:t> minh</a:t>
             </a:r>
             <a:r>
-              <a:rPr lang="en-US" sz="1950" dirty="0" spc="-3" kern="0">
+              <a:rPr lang="en-US" sz="1950" dirty="0" spc="-4" kern="0">
                 <a:solidFill>
                   <a:srgbClr val="9AA0B5"/>
                 </a:solidFill>
@@ -10756,26 +10756,26 @@
               <a:t> Qdisc</a:t>
             </a:r>
             <a:r>
-              <a:rPr lang="en-US" sz="2700" dirty="0" spc="-3" kern="0">
-                <a:solidFill>
-                  <a:srgbClr val="14161C"/>
-                </a:solidFill>
-                <a:latin typeface="Be Vietnam Pro" pitchFamily="34" charset="0"/>
-                <a:ea typeface="Be Vietnam Pro" pitchFamily="34" charset="-122"/>
-                <a:cs typeface="Be Vietnam Pro" pitchFamily="34" charset="-120"/>
-              </a:rPr>
-              <a:t> kiểm</a:t>
-            </a:r>
-            <a:r>
-              <a:rPr lang="en-US" sz="2700" dirty="0" spc="-20" kern="0">
-                <a:solidFill>
-                  <a:srgbClr val="14161C"/>
-                </a:solidFill>
-                <a:latin typeface="Be Vietnam Pro" pitchFamily="34" charset="0"/>
-                <a:ea typeface="Be Vietnam Pro" pitchFamily="34" charset="-122"/>
-                <a:cs typeface="Be Vietnam Pro" pitchFamily="34" charset="-120"/>
-              </a:rPr>
-              <a:t> soát</a:t>
+              <a:rPr lang="en-US" sz="2700" dirty="0" spc="-24" kern="0">
+                <a:solidFill>
+                  <a:srgbClr val="14161C"/>
+                </a:solidFill>
+                <a:latin typeface="Be Vietnam Pro" pitchFamily="34" charset="0"/>
+                <a:ea typeface="Be Vietnam Pro" pitchFamily="34" charset="-122"/>
+                <a:cs typeface="Be Vietnam Pro" pitchFamily="34" charset="-120"/>
+              </a:rPr>
+              <a:t> xếp</a:t>
+            </a:r>
+            <a:r>
+              <a:rPr lang="en-US" sz="2700" dirty="0" spc="-2" kern="0">
+                <a:solidFill>
+                  <a:srgbClr val="14161C"/>
+                </a:solidFill>
+                <a:latin typeface="Be Vietnam Pro" pitchFamily="34" charset="0"/>
+                <a:ea typeface="Be Vietnam Pro" pitchFamily="34" charset="-122"/>
+                <a:cs typeface="Be Vietnam Pro" pitchFamily="34" charset="-120"/>
+              </a:rPr>
+              <a:t> hàng</a:t>
             </a:r>
             <a:r>
               <a:rPr lang="en-US" sz="2700" dirty="0" spc="-1" kern="0">
@@ -10786,7 +10786,40 @@
                 <a:ea typeface="Be Vietnam Pro" pitchFamily="34" charset="-122"/>
                 <a:cs typeface="Be Vietnam Pro" pitchFamily="34" charset="-120"/>
               </a:rPr>
-              <a:t> luồng.</a:t>
+              <a:t> cho</a:t>
+            </a:r>
+            <a:r>
+              <a:rPr lang="en-US" sz="2700" dirty="0" spc="-15" kern="0">
+                <a:solidFill>
+                  <a:srgbClr val="14161C"/>
+                </a:solidFill>
+                <a:latin typeface="Be Vietnam Pro" pitchFamily="34" charset="0"/>
+                <a:ea typeface="Be Vietnam Pro" pitchFamily="34" charset="-122"/>
+                <a:cs typeface="Be Vietnam Pro" pitchFamily="34" charset="-120"/>
+              </a:rPr>
+              <a:t> gói</a:t>
+            </a:r>
+            <a:r>
+              <a:rPr lang="en-US" sz="2700" dirty="0" spc="35" kern="0">
+                <a:solidFill>
+                  <a:srgbClr val="14161C"/>
+                </a:solidFill>
+                <a:latin typeface="Be Vietnam Pro" pitchFamily="34" charset="0"/>
+                <a:ea typeface="Be Vietnam Pro" pitchFamily="34" charset="-122"/>
+                <a:cs typeface="Be Vietnam Pro" pitchFamily="34" charset="-120"/>
+              </a:rPr>
+              <a:t> đi</a:t>
+            </a:r>
+            <a:r>
+              <a:rPr lang="en-US" sz="2700" dirty="0" spc="-31" kern="0">
+                <a:solidFill>
+                  <a:srgbClr val="14161C"/>
+                </a:solidFill>
+                <a:latin typeface="Be Vietnam Pro" pitchFamily="34" charset="0"/>
+                <a:ea typeface="Be Vietnam Pro" pitchFamily="34" charset="-122"/>
+                <a:cs typeface="Be Vietnam Pro" pitchFamily="34" charset="-120"/>
+              </a:rPr>
+              <a:t> ra.</a:t>
             </a:r>
             <a:endParaRPr lang="en-US" sz="2700" dirty="0"/>
           </a:p>
@@ -11935,7 +11968,7 @@
               <a:buNone/>
             </a:pPr>
             <a:r>
-              <a:rPr lang="en-US" sz="2100" dirty="0" spc="3" kern="0">
+              <a:rPr lang="en-US" sz="2100" dirty="0" spc="-22" kern="0">
                 <a:solidFill>
                   <a:srgbClr val="1F3FD1"/>
                 </a:solidFill>
@@ -11943,10 +11976,10 @@
                 <a:ea typeface="Be Vietnam Pro" pitchFamily="34" charset="-122"/>
                 <a:cs typeface="Be Vietnam Pro" pitchFamily="34" charset="-120"/>
               </a:rPr>
-              <a:t>kiểm</a:t>
-            </a:r>
-            <a:r>
-              <a:rPr lang="en-US" sz="2100" dirty="0" spc="-16" kern="0">
+              <a:t>xếp</a:t>
+            </a:r>
+            <a:r>
+              <a:rPr lang="en-US" sz="2100" dirty="0" spc="-1" kern="0">
                 <a:solidFill>
                   <a:srgbClr val="1F3FD1"/>
                 </a:solidFill>
@@ -11954,10 +11987,10 @@
                 <a:ea typeface="Be Vietnam Pro" pitchFamily="34" charset="-122"/>
                 <a:cs typeface="Be Vietnam Pro" pitchFamily="34" charset="-120"/>
               </a:rPr>
-              <a:t> soát</a:t>
-            </a:r>
-            <a:r>
-              <a:rPr lang="en-US" sz="2100" dirty="0" spc="-1" kern="0">
+              <a:t> hàng</a:t>
+            </a:r>
+            <a:r>
+              <a:rPr lang="en-US" sz="2100" dirty="0" spc="-2" kern="0">
                 <a:solidFill>
                   <a:srgbClr val="1F3FD1"/>
                 </a:solidFill>
@@ -11965,7 +11998,40 @@
                 <a:ea typeface="Be Vietnam Pro" pitchFamily="34" charset="-122"/>
                 <a:cs typeface="Be Vietnam Pro" pitchFamily="34" charset="-120"/>
               </a:rPr>
-              <a:t> luồng</a:t>
+              <a:t> cho</a:t>
+            </a:r>
+            <a:r>
+              <a:rPr lang="en-US" sz="2100" dirty="0" spc="-12" kern="0">
+                <a:solidFill>
+                  <a:srgbClr val="1F3FD1"/>
+                </a:solidFill>
+                <a:latin typeface="Be Vietnam Pro" pitchFamily="34" charset="0"/>
+                <a:ea typeface="Be Vietnam Pro" pitchFamily="34" charset="-122"/>
+                <a:cs typeface="Be Vietnam Pro" pitchFamily="34" charset="-120"/>
+              </a:rPr>
+              <a:t> gói</a:t>
+            </a:r>
+            <a:r>
+              <a:rPr lang="en-US" sz="2100" dirty="0" spc="29" kern="0">
+                <a:solidFill>
+                  <a:srgbClr val="1F3FD1"/>
+                </a:solidFill>
+                <a:latin typeface="Be Vietnam Pro" pitchFamily="34" charset="0"/>
+                <a:ea typeface="Be Vietnam Pro" pitchFamily="34" charset="-122"/>
+                <a:cs typeface="Be Vietnam Pro" pitchFamily="34" charset="-120"/>
+              </a:rPr>
+              <a:t> đi</a:t>
+            </a:r>
+            <a:r>
+              <a:rPr lang="en-US" sz="2100" dirty="0" spc="-31" kern="0">
+                <a:solidFill>
+                  <a:srgbClr val="1F3FD1"/>
+                </a:solidFill>
+                <a:latin typeface="Be Vietnam Pro" pitchFamily="34" charset="0"/>
+                <a:ea typeface="Be Vietnam Pro" pitchFamily="34" charset="-122"/>
+                <a:cs typeface="Be Vietnam Pro" pitchFamily="34" charset="-120"/>
+              </a:rPr>
+              <a:t> ra</a:t>
             </a:r>
             <a:endParaRPr lang="en-US" sz="2400" dirty="0"/>
           </a:p>
@@ -12749,6 +12815,39 @@
               <a:buNone/>
             </a:pPr>
             <a:r>
+              <a:rPr lang="en-US" sz="2700" dirty="0" spc="1" kern="0">
+                <a:solidFill>
+                  <a:srgbClr val="C4C8D6"/>
+                </a:solidFill>
+                <a:latin typeface="Be Vietnam Pro" pitchFamily="34" charset="0"/>
+                <a:ea typeface="Be Vietnam Pro" pitchFamily="34" charset="-122"/>
+                <a:cs typeface="Be Vietnam Pro" pitchFamily="34" charset="-120"/>
+              </a:rPr>
+              <a:t>NIC</a:t>
+            </a:r>
+            <a:r>
+              <a:rPr lang="en-US" sz="2700" dirty="0" spc="-11" kern="0">
+                <a:solidFill>
+                  <a:srgbClr val="C4C8D6"/>
+                </a:solidFill>
+                <a:latin typeface="Be Vietnam Pro" pitchFamily="34" charset="0"/>
+                <a:ea typeface="Be Vietnam Pro" pitchFamily="34" charset="-122"/>
+                <a:cs typeface="Be Vietnam Pro" pitchFamily="34" charset="-120"/>
+              </a:rPr>
+              <a:t> lấy</a:t>
+            </a:r>
+            <a:r>
+              <a:rPr lang="en-US" sz="2700" dirty="0" spc="-15" kern="0">
+                <a:solidFill>
+                  <a:srgbClr val="C4C8D6"/>
+                </a:solidFill>
+                <a:latin typeface="Be Vietnam Pro" pitchFamily="34" charset="0"/>
+                <a:ea typeface="Be Vietnam Pro" pitchFamily="34" charset="-122"/>
+                <a:cs typeface="Be Vietnam Pro" pitchFamily="34" charset="-120"/>
+              </a:rPr>
+              <a:t> gói</a:t>
+            </a:r>
+            <a:r>
               <a:rPr lang="en-US" sz="2700" dirty="0" spc="-1" kern="0">
                 <a:solidFill>
                   <a:srgbClr val="C4C8D6"/>
@@ -12757,10 +12856,10 @@
                 <a:ea typeface="Be Vietnam Pro" pitchFamily="34" charset="-122"/>
                 <a:cs typeface="Be Vietnam Pro" pitchFamily="34" charset="-120"/>
               </a:rPr>
-              <a:t>Dữ liệu</a:t>
-            </a:r>
-            <a:r>
-              <a:rPr lang="en-US" sz="2700" dirty="0" spc="-13" kern="0">
+              <a:t> từ</a:t>
+            </a:r>
+            <a:r>
+              <a:rPr lang="en-US" sz="2700" dirty="0" spc="-7" kern="0">
                 <a:solidFill>
                   <a:srgbClr val="C4C8D6"/>
                 </a:solidFill>
@@ -12768,10 +12867,10 @@
                 <a:ea typeface="Be Vietnam Pro" pitchFamily="34" charset="-122"/>
                 <a:cs typeface="Be Vietnam Pro" pitchFamily="34" charset="-120"/>
               </a:rPr>
-              <a:t> tới</a:t>
-            </a:r>
-            <a:r>
-              <a:rPr lang="en-US" sz="2700" dirty="0" spc="-1" kern="0">
+              <a:t> bộ</a:t>
+            </a:r>
+            <a:r>
+              <a:rPr lang="en-US" sz="2700" dirty="0" spc="10" kern="0">
                 <a:solidFill>
                   <a:srgbClr val="C4C8D6"/>
                 </a:solidFill>
@@ -12779,10 +12878,10 @@
                 <a:ea typeface="Be Vietnam Pro" pitchFamily="34" charset="-122"/>
                 <a:cs typeface="Be Vietnam Pro" pitchFamily="34" charset="-120"/>
               </a:rPr>
-              <a:t> NIC qua</a:t>
-            </a:r>
-            <a:r>
-              <a:rPr lang="en-US" sz="2700" dirty="0" spc="-8" kern="0">
+              <a:t> đệm</a:t>
+            </a:r>
+            <a:r>
+              <a:rPr lang="en-US" sz="2700" dirty="0" spc="-12" kern="0">
                 <a:solidFill>
                   <a:srgbClr val="C4C8D6"/>
                 </a:solidFill>
@@ -12790,10 +12889,10 @@
                 <a:ea typeface="Be Vietnam Pro" pitchFamily="34" charset="-122"/>
                 <a:cs typeface="Be Vietnam Pro" pitchFamily="34" charset="-120"/>
               </a:rPr>
-              <a:t> một</a:t>
-            </a:r>
-            <a:r>
-              <a:rPr lang="en-US" sz="2700" dirty="0" spc="-7" kern="0">
+              <a:t> vòng</a:t>
+            </a:r>
+            <a:r>
+              <a:rPr lang="en-US" sz="2700" dirty="0" spc="-29" kern="0">
                 <a:solidFill>
                   <a:srgbClr val="C4C8D6"/>
                 </a:solidFill>
@@ -12801,10 +12900,10 @@
                 <a:ea typeface="Be Vietnam Pro" pitchFamily="34" charset="-122"/>
                 <a:cs typeface="Be Vietnam Pro" pitchFamily="34" charset="-120"/>
               </a:rPr>
-              <a:t> bộ</a:t>
-            </a:r>
-            <a:r>
-              <a:rPr lang="en-US" sz="2700" dirty="0" spc="11" kern="0">
+              <a:t> rồi</a:t>
+            </a:r>
+            <a:r>
+              <a:rPr lang="en-US" sz="2700" dirty="0" spc="9" kern="0">
                 <a:solidFill>
                   <a:srgbClr val="C4C8D6"/>
                 </a:solidFill>
@@ -12812,10 +12911,10 @@
                 <a:ea typeface="Be Vietnam Pro" pitchFamily="34" charset="-122"/>
                 <a:cs typeface="Be Vietnam Pro" pitchFamily="34" charset="-120"/>
               </a:rPr>
-              <a:t> đệm</a:t>
-            </a:r>
-            <a:r>
-              <a:rPr lang="en-US" sz="2700" dirty="0" spc="-10" kern="0">
+              <a:t> đưa</a:t>
+            </a:r>
+            <a:r>
+              <a:rPr lang="en-US" sz="2700" dirty="0" spc="-2" kern="0">
                 <a:solidFill>
                   <a:srgbClr val="C4C8D6"/>
                 </a:solidFill>
@@ -12823,54 +12922,10 @@
                 <a:ea typeface="Be Vietnam Pro" pitchFamily="34" charset="-122"/>
                 <a:cs typeface="Be Vietnam Pro" pitchFamily="34" charset="-120"/>
               </a:rPr>
-              <a:t> vòng.</a:t>
-            </a:r>
-            <a:r>
-              <a:rPr lang="en-US" sz="2700" dirty="0" spc="-1" kern="0">
-                <a:solidFill>
-                  <a:srgbClr val="C4C8D6"/>
-                </a:solidFill>
-                <a:latin typeface="Be Vietnam Pro" pitchFamily="34" charset="0"/>
-                <a:ea typeface="Be Vietnam Pro" pitchFamily="34" charset="-122"/>
-                <a:cs typeface="Be Vietnam Pro" pitchFamily="34" charset="-120"/>
-              </a:rPr>
-              <a:t> NIC</a:t>
-            </a:r>
-            <a:r>
-              <a:rPr lang="en-US" sz="2700" dirty="0" spc="10" kern="0">
-                <a:solidFill>
-                  <a:srgbClr val="C4C8D6"/>
-                </a:solidFill>
-                <a:latin typeface="Be Vietnam Pro" pitchFamily="34" charset="0"/>
-                <a:ea typeface="Be Vietnam Pro" pitchFamily="34" charset="-122"/>
-                <a:cs typeface="Be Vietnam Pro" pitchFamily="34" charset="-120"/>
-              </a:rPr>
-              <a:t> đưa</a:t>
-            </a:r>
-            <a:r>
-              <a:rPr lang="en-US" sz="2700" dirty="0" spc="-4" kern="0">
-                <a:solidFill>
-                  <a:srgbClr val="C4C8D6"/>
-                </a:solidFill>
-                <a:latin typeface="Be Vietnam Pro" pitchFamily="34" charset="0"/>
-                <a:ea typeface="Be Vietnam Pro" pitchFamily="34" charset="-122"/>
-                <a:cs typeface="Be Vietnam Pro" pitchFamily="34" charset="-120"/>
-              </a:rPr>
-              <a:t> nó</a:t>
-            </a:r>
-            <a:r>
-              <a:rPr lang="en-US" sz="2700" dirty="0" spc="-3" kern="0">
-                <a:solidFill>
-                  <a:srgbClr val="C4C8D6"/>
-                </a:solidFill>
-                <a:latin typeface="Be Vietnam Pro" pitchFamily="34" charset="0"/>
-                <a:ea typeface="Be Vietnam Pro" pitchFamily="34" charset="-122"/>
-                <a:cs typeface="Be Vietnam Pro" pitchFamily="34" charset="-120"/>
-              </a:rPr>
               <a:t> lên</a:t>
             </a:r>
             <a:r>
-              <a:rPr lang="en-US" sz="2700" dirty="0" spc="-13" kern="0">
+              <a:rPr lang="en-US" sz="2700" dirty="0" spc="-14" kern="0">
                 <a:solidFill>
                   <a:srgbClr val="C4C8D6"/>
                 </a:solidFill>
@@ -14798,7 +14853,7 @@
               <a:buNone/>
             </a:pPr>
             <a:r>
-              <a:rPr lang="en-US" sz="7200" dirty="0" spc="-17" kern="0">
+              <a:rPr lang="en-US" sz="7200" dirty="0" spc="3" kern="0">
                 <a:solidFill>
                   <a:srgbClr val="14161C"/>
                 </a:solidFill>
@@ -14806,18 +14861,7 @@
                 <a:ea typeface="Bricolage Grotesque ExtraBold" pitchFamily="34" charset="-122"/>
                 <a:cs typeface="Bricolage Grotesque ExtraBold" pitchFamily="34" charset="-120"/>
               </a:rPr>
-              <a:t>Ngắt</a:t>
-            </a:r>
-            <a:r>
-              <a:rPr lang="en-US" sz="7200" dirty="0" spc="30" kern="0">
-                <a:solidFill>
-                  <a:srgbClr val="14161C"/>
-                </a:solidFill>
-                <a:latin typeface="Bricolage Grotesque ExtraBold" pitchFamily="34" charset="0"/>
-                <a:ea typeface="Bricolage Grotesque ExtraBold" pitchFamily="34" charset="-122"/>
-                <a:cs typeface="Bricolage Grotesque ExtraBold" pitchFamily="34" charset="-120"/>
-              </a:rPr>
-              <a:t> cứng,</a:t>
+              <a:t>Ngắt,</a:t>
             </a:r>
             <a:endParaRPr lang="en-US" sz="7200" dirty="0"/>
           </a:p>
@@ -14976,37 +15020,15 @@
               <a:buNone/>
             </a:pPr>
             <a:r>
-              <a:rPr lang="en-US" sz="2700" dirty="0" spc="1" kern="0">
-                <a:solidFill>
-                  <a:srgbClr val="14161C"/>
-                </a:solidFill>
-                <a:latin typeface="Be Vietnam Pro" pitchFamily="34" charset="0"/>
-                <a:ea typeface="Be Vietnam Pro" pitchFamily="34" charset="-122"/>
-                <a:cs typeface="Be Vietnam Pro" pitchFamily="34" charset="-120"/>
-              </a:rPr>
-              <a:t>NIC đặt</a:t>
-            </a:r>
-            <a:r>
-              <a:rPr lang="en-US" sz="2700" dirty="0" spc="-4" kern="0">
-                <a:solidFill>
-                  <a:srgbClr val="14161C"/>
-                </a:solidFill>
-                <a:latin typeface="Be Vietnam Pro" pitchFamily="34" charset="0"/>
-                <a:ea typeface="Be Vietnam Pro" pitchFamily="34" charset="-122"/>
-                <a:cs typeface="Be Vietnam Pro" pitchFamily="34" charset="-120"/>
-              </a:rPr>
-              <a:t> dữ</a:t>
-            </a:r>
-            <a:r>
-              <a:rPr lang="en-US" sz="2700" dirty="0" spc="-1" kern="0">
-                <a:solidFill>
-                  <a:srgbClr val="14161C"/>
-                </a:solidFill>
-                <a:latin typeface="Be Vietnam Pro" pitchFamily="34" charset="0"/>
-                <a:ea typeface="Be Vietnam Pro" pitchFamily="34" charset="-122"/>
-                <a:cs typeface="Be Vietnam Pro" pitchFamily="34" charset="-120"/>
-              </a:rPr>
-              <a:t> liệu</a:t>
+              <a:rPr lang="en-US" sz="2700" dirty="0" spc="0" kern="0">
+                <a:solidFill>
+                  <a:srgbClr val="14161C"/>
+                </a:solidFill>
+                <a:latin typeface="Be Vietnam Pro" pitchFamily="34" charset="0"/>
+                <a:ea typeface="Be Vietnam Pro" pitchFamily="34" charset="-122"/>
+                <a:cs typeface="Be Vietnam Pro" pitchFamily="34" charset="-120"/>
+              </a:rPr>
+              <a:t>Gói</a:t>
             </a:r>
             <a:r>
               <a:rPr lang="en-US" sz="2700" dirty="0" spc="-14" kern="0">
@@ -15042,26 +15064,26 @@
               <a:t> đệm</a:t>
             </a:r>
             <a:r>
-              <a:rPr lang="en-US" sz="2700" dirty="0" spc="-12" kern="0">
-                <a:solidFill>
-                  <a:srgbClr val="14161C"/>
-                </a:solidFill>
-                <a:latin typeface="Be Vietnam Pro" pitchFamily="34" charset="0"/>
-                <a:ea typeface="Be Vietnam Pro" pitchFamily="34" charset="-122"/>
-                <a:cs typeface="Be Vietnam Pro" pitchFamily="34" charset="-120"/>
-              </a:rPr>
-              <a:t> vòng</a:t>
-            </a:r>
-            <a:r>
-              <a:rPr lang="en-US" sz="2700" dirty="0" spc="-29" kern="0">
-                <a:solidFill>
-                  <a:srgbClr val="14161C"/>
-                </a:solidFill>
-                <a:latin typeface="Be Vietnam Pro" pitchFamily="34" charset="0"/>
-                <a:ea typeface="Be Vietnam Pro" pitchFamily="34" charset="-122"/>
-                <a:cs typeface="Be Vietnam Pro" pitchFamily="34" charset="-120"/>
-              </a:rPr>
-              <a:t> rồi</a:t>
+              <a:rPr lang="en-US" sz="2700" dirty="0" spc="-9" kern="0">
+                <a:solidFill>
+                  <a:srgbClr val="14161C"/>
+                </a:solidFill>
+                <a:latin typeface="Be Vietnam Pro" pitchFamily="34" charset="0"/>
+                <a:ea typeface="Be Vietnam Pro" pitchFamily="34" charset="-122"/>
+                <a:cs typeface="Be Vietnam Pro" pitchFamily="34" charset="-120"/>
+              </a:rPr>
+              <a:t> vòng;</a:t>
+            </a:r>
+            <a:r>
+              <a:rPr lang="en-US" sz="2700" dirty="0" spc="0" kern="0">
+                <a:solidFill>
+                  <a:srgbClr val="14161C"/>
+                </a:solidFill>
+                <a:latin typeface="Be Vietnam Pro" pitchFamily="34" charset="0"/>
+                <a:ea typeface="Be Vietnam Pro" pitchFamily="34" charset="-122"/>
+                <a:cs typeface="Be Vietnam Pro" pitchFamily="34" charset="-120"/>
+              </a:rPr>
+              <a:t> NIC</a:t>
             </a:r>
             <a:r>
               <a:rPr lang="en-US" sz="2700" dirty="0" spc="-6" kern="0">
@@ -15075,15 +15097,37 @@
               <a:t> báo</a:t>
             </a:r>
             <a:r>
-              <a:rPr lang="en-US" sz="2700" dirty="0" spc="-1" kern="0">
-                <a:solidFill>
-                  <a:srgbClr val="14161C"/>
-                </a:solidFill>
-                <a:latin typeface="Be Vietnam Pro" pitchFamily="34" charset="0"/>
-                <a:ea typeface="Be Vietnam Pro" pitchFamily="34" charset="-122"/>
-                <a:cs typeface="Be Vietnam Pro" pitchFamily="34" charset="-120"/>
-              </a:rPr>
-              <a:t> CPU.</a:t>
+              <a:rPr lang="en-US" sz="2700" dirty="0" spc="0" kern="0">
+                <a:solidFill>
+                  <a:srgbClr val="14161C"/>
+                </a:solidFill>
+                <a:latin typeface="Be Vietnam Pro" pitchFamily="34" charset="0"/>
+                <a:ea typeface="Be Vietnam Pro" pitchFamily="34" charset="-122"/>
+                <a:cs typeface="Be Vietnam Pro" pitchFamily="34" charset="-120"/>
+              </a:rPr>
+              <a:t> CPU</a:t>
+            </a:r>
+            <a:r>
+              <a:rPr lang="en-US" sz="2700" dirty="0" spc="-5" kern="0">
+                <a:solidFill>
+                  <a:srgbClr val="14161C"/>
+                </a:solidFill>
+                <a:latin typeface="Be Vietnam Pro" pitchFamily="34" charset="0"/>
+                <a:ea typeface="Be Vietnam Pro" pitchFamily="34" charset="-122"/>
+                <a:cs typeface="Be Vietnam Pro" pitchFamily="34" charset="-120"/>
+              </a:rPr>
+              <a:t> bằng</a:t>
+            </a:r>
+            <a:r>
+              <a:rPr lang="en-US" sz="2700" dirty="0" spc="-19" kern="0">
+                <a:solidFill>
+                  <a:srgbClr val="14161C"/>
+                </a:solidFill>
+                <a:latin typeface="Be Vietnam Pro" pitchFamily="34" charset="0"/>
+                <a:ea typeface="Be Vietnam Pro" pitchFamily="34" charset="-122"/>
+                <a:cs typeface="Be Vietnam Pro" pitchFamily="34" charset="-120"/>
+              </a:rPr>
+              <a:t> ngắt.</a:t>
             </a:r>
             <a:endParaRPr lang="en-US" sz="2700" dirty="0"/>
           </a:p>
@@ -15127,17 +15171,6 @@
                 <a:cs typeface="Be Vietnam Pro" pitchFamily="34" charset="-120"/>
               </a:rPr>
               <a:t>ngắt</a:t>
-            </a:r>
-            <a:r>
-              <a:rPr lang="en-US" sz="2100" b="1" dirty="0" spc="18" kern="0">
-                <a:solidFill>
-                  <a:srgbClr val="F3EEE3"/>
-                </a:solidFill>
-                <a:latin typeface="Be Vietnam Pro" pitchFamily="34" charset="0"/>
-                <a:ea typeface="Be Vietnam Pro" pitchFamily="34" charset="-122"/>
-                <a:cs typeface="Be Vietnam Pro" pitchFamily="34" charset="-120"/>
-              </a:rPr>
-              <a:t> cứng</a:t>
             </a:r>
             <a:endParaRPr lang="en-US" sz="2100" dirty="0"/>
           </a:p>
@@ -15334,26 +15367,15 @@
               <a:buChar char="•"/>
             </a:pPr>
             <a:r>
-              <a:rPr lang="en-US" sz="2400" dirty="0" spc="-22" kern="0">
-                <a:solidFill>
-                  <a:srgbClr val="14161C"/>
-                </a:solidFill>
-                <a:latin typeface="Be Vietnam Pro" pitchFamily="34" charset="0"/>
-                <a:ea typeface="Be Vietnam Pro" pitchFamily="34" charset="-122"/>
-                <a:cs typeface="Be Vietnam Pro" pitchFamily="34" charset="-120"/>
-              </a:rPr>
-              <a:t>Ngắt</a:t>
-            </a:r>
-            <a:r>
-              <a:rPr lang="en-US" sz="2400" dirty="0" spc="17" kern="0">
-                <a:solidFill>
-                  <a:srgbClr val="14161C"/>
-                </a:solidFill>
-                <a:latin typeface="Be Vietnam Pro" pitchFamily="34" charset="0"/>
-                <a:ea typeface="Be Vietnam Pro" pitchFamily="34" charset="-122"/>
-                <a:cs typeface="Be Vietnam Pro" pitchFamily="34" charset="-120"/>
-              </a:rPr>
-              <a:t> cứng:</a:t>
+              <a:rPr lang="en-US" sz="2400" dirty="0" spc="-18" kern="0">
+                <a:solidFill>
+                  <a:srgbClr val="14161C"/>
+                </a:solidFill>
+                <a:latin typeface="Be Vietnam Pro" pitchFamily="34" charset="0"/>
+                <a:ea typeface="Be Vietnam Pro" pitchFamily="34" charset="-122"/>
+                <a:cs typeface="Be Vietnam Pro" pitchFamily="34" charset="-120"/>
+              </a:rPr>
+              <a:t>Ngắt:</a:t>
             </a:r>
             <a:r>
               <a:rPr lang="en-US" sz="2400" dirty="0" spc="-3" kern="0">
@@ -15367,7 +15389,7 @@
               <a:t> NIC</a:t>
             </a:r>
             <a:r>
-              <a:rPr lang="en-US" sz="2400" dirty="0" spc="1" kern="0">
+              <a:rPr lang="en-US" sz="2400" dirty="0" spc="0" kern="0">
                 <a:solidFill>
                   <a:srgbClr val="14161C"/>
                 </a:solidFill>
@@ -15425,26 +15447,48 @@
               <a:t> mềm:</a:t>
             </a:r>
             <a:r>
-              <a:rPr lang="en-US" sz="2400" dirty="0" spc="-1" kern="0">
-                <a:solidFill>
-                  <a:srgbClr val="14161C"/>
-                </a:solidFill>
-                <a:latin typeface="Be Vietnam Pro" pitchFamily="34" charset="0"/>
-                <a:ea typeface="Be Vietnam Pro" pitchFamily="34" charset="-122"/>
-                <a:cs typeface="Be Vietnam Pro" pitchFamily="34" charset="-120"/>
-              </a:rPr>
-              <a:t> CPU</a:t>
-            </a:r>
-            <a:r>
-              <a:rPr lang="en-US" sz="2400" dirty="0" spc="1" kern="0">
-                <a:solidFill>
-                  <a:srgbClr val="14161C"/>
-                </a:solidFill>
-                <a:latin typeface="Be Vietnam Pro" pitchFamily="34" charset="0"/>
-                <a:ea typeface="Be Vietnam Pro" pitchFamily="34" charset="-122"/>
-                <a:cs typeface="Be Vietnam Pro" pitchFamily="34" charset="-120"/>
-              </a:rPr>
-              <a:t> báo</a:t>
+              <a:rPr lang="en-US" sz="2400" dirty="0" spc="-7" kern="0">
+                <a:solidFill>
+                  <a:srgbClr val="14161C"/>
+                </a:solidFill>
+                <a:latin typeface="Be Vietnam Pro" pitchFamily="34" charset="0"/>
+                <a:ea typeface="Be Vietnam Pro" pitchFamily="34" charset="-122"/>
+                <a:cs typeface="Be Vietnam Pro" pitchFamily="34" charset="-120"/>
+              </a:rPr>
+              <a:t> chạy</a:t>
+            </a:r>
+            <a:r>
+              <a:rPr lang="en-US" sz="2400" dirty="0" spc="-15" kern="0">
+                <a:solidFill>
+                  <a:srgbClr val="14161C"/>
+                </a:solidFill>
+                <a:latin typeface="Be Vietnam Pro" pitchFamily="34" charset="0"/>
+                <a:ea typeface="Be Vietnam Pro" pitchFamily="34" charset="-122"/>
+                <a:cs typeface="Be Vietnam Pro" pitchFamily="34" charset="-120"/>
+              </a:rPr>
+              <a:t> ngay</a:t>
+            </a:r>
+            <a:r>
+              <a:rPr lang="en-US" sz="2400" dirty="0" spc="-2" kern="0">
+                <a:solidFill>
+                  <a:srgbClr val="14161C"/>
+                </a:solidFill>
+                <a:latin typeface="Be Vietnam Pro" pitchFamily="34" charset="0"/>
+                <a:ea typeface="Be Vietnam Pro" pitchFamily="34" charset="-122"/>
+                <a:cs typeface="Be Vietnam Pro" pitchFamily="34" charset="-120"/>
+              </a:rPr>
+              <a:t> khi</a:t>
+            </a:r>
+            <a:r>
+              <a:rPr lang="en-US" sz="2400" dirty="0" spc="-7" kern="0">
+                <a:solidFill>
+                  <a:srgbClr val="14161C"/>
+                </a:solidFill>
+                <a:latin typeface="Be Vietnam Pro" pitchFamily="34" charset="0"/>
+                <a:ea typeface="Be Vietnam Pro" pitchFamily="34" charset="-122"/>
+                <a:cs typeface="Be Vietnam Pro" pitchFamily="34" charset="-120"/>
+              </a:rPr>
+              <a:t> thoát</a:t>
             </a:r>
             <a:r>
               <a:rPr lang="en-US" sz="2400" dirty="0" spc="-17" kern="0">
@@ -15455,7 +15499,7 @@
                 <a:ea typeface="Be Vietnam Pro" pitchFamily="34" charset="-122"/>
                 <a:cs typeface="Be Vietnam Pro" pitchFamily="34" charset="-120"/>
               </a:rPr>
-              <a:t> ksoftirqd</a:t>
+              <a:t> ngắt</a:t>
             </a:r>
             <a:endParaRPr lang="en-US" sz="2400" dirty="0"/>
           </a:p>
@@ -15469,26 +15513,15 @@
               <a:buChar char="•"/>
             </a:pPr>
             <a:r>
-              <a:rPr lang="en-US" sz="2400" dirty="0" spc="-19" kern="0">
-                <a:solidFill>
-                  <a:srgbClr val="14161C"/>
-                </a:solidFill>
-                <a:latin typeface="Be Vietnam Pro" pitchFamily="34" charset="0"/>
-                <a:ea typeface="Be Vietnam Pro" pitchFamily="34" charset="-122"/>
-                <a:cs typeface="Be Vietnam Pro" pitchFamily="34" charset="-120"/>
-              </a:rPr>
-              <a:t>ksoftirqd</a:t>
-            </a:r>
-            <a:r>
-              <a:rPr lang="en-US" sz="2400" dirty="0" spc="-7" kern="0">
-                <a:solidFill>
-                  <a:srgbClr val="14161C"/>
-                </a:solidFill>
-                <a:latin typeface="Be Vietnam Pro" pitchFamily="34" charset="0"/>
-                <a:ea typeface="Be Vietnam Pro" pitchFamily="34" charset="-122"/>
-                <a:cs typeface="Be Vietnam Pro" pitchFamily="34" charset="-120"/>
-              </a:rPr>
-              <a:t> lấy</a:t>
+              <a:rPr lang="en-US" sz="2400" dirty="0" spc="-11" kern="0">
+                <a:solidFill>
+                  <a:srgbClr val="14161C"/>
+                </a:solidFill>
+                <a:latin typeface="Be Vietnam Pro" pitchFamily="34" charset="0"/>
+                <a:ea typeface="Be Vietnam Pro" pitchFamily="34" charset="-122"/>
+                <a:cs typeface="Be Vietnam Pro" pitchFamily="34" charset="-120"/>
+              </a:rPr>
+              <a:t>Ngoài</a:t>
             </a:r>
             <a:r>
               <a:rPr lang="en-US" sz="2400" dirty="0" spc="3" kern="0">
@@ -15499,62 +15532,62 @@
                 <a:ea typeface="Be Vietnam Pro" pitchFamily="34" charset="-122"/>
                 <a:cs typeface="Be Vietnam Pro" pitchFamily="34" charset="-120"/>
               </a:rPr>
-              <a:t> dữ</a:t>
-            </a:r>
-            <a:r>
-              <a:rPr lang="en-US" sz="2400" dirty="0" spc="-1" kern="0">
-                <a:solidFill>
-                  <a:srgbClr val="14161C"/>
-                </a:solidFill>
-                <a:latin typeface="Be Vietnam Pro" pitchFamily="34" charset="0"/>
-                <a:ea typeface="Be Vietnam Pro" pitchFamily="34" charset="-122"/>
-                <a:cs typeface="Be Vietnam Pro" pitchFamily="34" charset="-120"/>
-              </a:rPr>
-              <a:t> liệu</a:t>
-            </a:r>
-            <a:r>
-              <a:rPr lang="en-US" sz="2400" dirty="0" spc="3" kern="0">
-                <a:solidFill>
-                  <a:srgbClr val="14161C"/>
-                </a:solidFill>
-                <a:latin typeface="Be Vietnam Pro" pitchFamily="34" charset="0"/>
-                <a:ea typeface="Be Vietnam Pro" pitchFamily="34" charset="-122"/>
-                <a:cs typeface="Be Vietnam Pro" pitchFamily="34" charset="-120"/>
-              </a:rPr>
-              <a:t> từ</a:t>
-            </a:r>
-            <a:r>
-              <a:rPr lang="en-US" sz="2400" dirty="0" spc="-2" kern="0">
-                <a:solidFill>
-                  <a:srgbClr val="14161C"/>
-                </a:solidFill>
-                <a:latin typeface="Be Vietnam Pro" pitchFamily="34" charset="0"/>
-                <a:ea typeface="Be Vietnam Pro" pitchFamily="34" charset="-122"/>
-                <a:cs typeface="Be Vietnam Pro" pitchFamily="34" charset="-120"/>
-              </a:rPr>
-              <a:t> bộ</a:t>
-            </a:r>
-            <a:r>
-              <a:rPr lang="en-US" sz="2400" dirty="0" spc="14" kern="0">
-                <a:solidFill>
-                  <a:srgbClr val="14161C"/>
-                </a:solidFill>
-                <a:latin typeface="Be Vietnam Pro" pitchFamily="34" charset="0"/>
-                <a:ea typeface="Be Vietnam Pro" pitchFamily="34" charset="-122"/>
-                <a:cs typeface="Be Vietnam Pro" pitchFamily="34" charset="-120"/>
-              </a:rPr>
-              <a:t> đệm</a:t>
-            </a:r>
-            <a:r>
-              <a:rPr lang="en-US" sz="2400" dirty="0" spc="-8" kern="0">
-                <a:solidFill>
-                  <a:srgbClr val="14161C"/>
-                </a:solidFill>
-                <a:latin typeface="Be Vietnam Pro" pitchFamily="34" charset="0"/>
-                <a:ea typeface="Be Vietnam Pro" pitchFamily="34" charset="-122"/>
-                <a:cs typeface="Be Vietnam Pro" pitchFamily="34" charset="-120"/>
-              </a:rPr>
-              <a:t> vòng</a:t>
+              <a:t> ngữ</a:t>
+            </a:r>
+            <a:r>
+              <a:rPr lang="en-US" sz="2400" dirty="0" spc="1" kern="0">
+                <a:solidFill>
+                  <a:srgbClr val="14161C"/>
+                </a:solidFill>
+                <a:latin typeface="Be Vietnam Pro" pitchFamily="34" charset="0"/>
+                <a:ea typeface="Be Vietnam Pro" pitchFamily="34" charset="-122"/>
+                <a:cs typeface="Be Vietnam Pro" pitchFamily="34" charset="-120"/>
+              </a:rPr>
+              <a:t> cảnh</a:t>
+            </a:r>
+            <a:r>
+              <a:rPr lang="en-US" sz="2400" dirty="0" spc="-14" kern="0">
+                <a:solidFill>
+                  <a:srgbClr val="14161C"/>
+                </a:solidFill>
+                <a:latin typeface="Be Vietnam Pro" pitchFamily="34" charset="0"/>
+                <a:ea typeface="Be Vietnam Pro" pitchFamily="34" charset="-122"/>
+                <a:cs typeface="Be Vietnam Pro" pitchFamily="34" charset="-120"/>
+              </a:rPr>
+              <a:t> ngắt:</a:t>
+            </a:r>
+            <a:r>
+              <a:rPr lang="en-US" sz="2400" dirty="0" spc="-17" kern="0">
+                <a:solidFill>
+                  <a:srgbClr val="14161C"/>
+                </a:solidFill>
+                <a:latin typeface="Be Vietnam Pro" pitchFamily="34" charset="0"/>
+                <a:ea typeface="Be Vietnam Pro" pitchFamily="34" charset="-122"/>
+                <a:cs typeface="Be Vietnam Pro" pitchFamily="34" charset="-120"/>
+              </a:rPr>
+              <a:t> ksoftirqd</a:t>
+            </a:r>
+            <a:r>
+              <a:rPr lang="en-US" sz="2400" dirty="0" spc="-6" kern="0">
+                <a:solidFill>
+                  <a:srgbClr val="14161C"/>
+                </a:solidFill>
+                <a:latin typeface="Be Vietnam Pro" pitchFamily="34" charset="0"/>
+                <a:ea typeface="Be Vietnam Pro" pitchFamily="34" charset="-122"/>
+                <a:cs typeface="Be Vietnam Pro" pitchFamily="34" charset="-120"/>
+              </a:rPr>
+              <a:t> chạy</a:t>
+            </a:r>
+            <a:r>
+              <a:rPr lang="en-US" sz="2400" dirty="0" spc="1" kern="0">
+                <a:solidFill>
+                  <a:srgbClr val="14161C"/>
+                </a:solidFill>
+                <a:latin typeface="Be Vietnam Pro" pitchFamily="34" charset="0"/>
+                <a:ea typeface="Be Vietnam Pro" pitchFamily="34" charset="-122"/>
+                <a:cs typeface="Be Vietnam Pro" pitchFamily="34" charset="-120"/>
+              </a:rPr>
+              <a:t> nó</a:t>
             </a:r>
             <a:endParaRPr lang="en-US" sz="2400" dirty="0"/>
           </a:p>
@@ -16059,17 +16092,6 @@
               </a:rPr>
               <a:t>ngắt</a:t>
             </a:r>
-            <a:r>
-              <a:rPr lang="en-US" sz="1998" b="1" dirty="0" spc="16" kern="0">
-                <a:solidFill>
-                  <a:srgbClr val="0F766E"/>
-                </a:solidFill>
-                <a:latin typeface="Be Vietnam Pro" pitchFamily="34" charset="0"/>
-                <a:ea typeface="Be Vietnam Pro" pitchFamily="34" charset="-122"/>
-                <a:cs typeface="Be Vietnam Pro" pitchFamily="34" charset="-120"/>
-              </a:rPr>
-              <a:t> cứng</a:t>
-            </a:r>
             <a:endParaRPr lang="en-US" sz="1998" dirty="0"/>
           </a:p>
         </p:txBody>
@@ -16203,7 +16225,7 @@
               <a:buNone/>
             </a:pPr>
             <a:r>
-              <a:rPr lang="en-US" sz="1950" b="1" dirty="0" spc="-10" kern="0">
+              <a:rPr lang="en-US" sz="1950" b="1" dirty="0" spc="-2" kern="0">
                 <a:solidFill>
                   <a:srgbClr val="0F766E"/>
                 </a:solidFill>
@@ -16211,10 +16233,10 @@
                 <a:ea typeface="Be Vietnam Pro" pitchFamily="34" charset="-122"/>
                 <a:cs typeface="Be Vietnam Pro" pitchFamily="34" charset="-120"/>
               </a:rPr>
-              <a:t>lấy</a:t>
-            </a:r>
-            <a:r>
-              <a:rPr lang="en-US" sz="1950" b="1" dirty="0" spc="0" kern="0">
+              <a:t>xử</a:t>
+            </a:r>
+            <a:r>
+              <a:rPr lang="en-US" sz="1950" b="1" dirty="0" spc="-1" kern="0">
                 <a:solidFill>
                   <a:srgbClr val="0F766E"/>
                 </a:solidFill>
@@ -16222,7 +16244,18 @@
                 <a:ea typeface="Be Vietnam Pro" pitchFamily="34" charset="-122"/>
                 <a:cs typeface="Be Vietnam Pro" pitchFamily="34" charset="-120"/>
               </a:rPr>
-              <a:t> dữ liệu</a:t>
+              <a:t> lý</a:t>
+            </a:r>
+            <a:r>
+              <a:rPr lang="en-US" sz="1950" b="1" dirty="0" spc="-5" kern="0">
+                <a:solidFill>
+                  <a:srgbClr val="0F766E"/>
+                </a:solidFill>
+                <a:latin typeface="Be Vietnam Pro" pitchFamily="34" charset="0"/>
+                <a:ea typeface="Be Vietnam Pro" pitchFamily="34" charset="-122"/>
+                <a:cs typeface="Be Vietnam Pro" pitchFamily="34" charset="-120"/>
+              </a:rPr>
+              <a:t> gói</a:t>
             </a:r>
             <a:endParaRPr lang="en-US" sz="1950" dirty="0"/>
           </a:p>
@@ -20334,7 +20367,7 @@
               <a:buNone/>
             </a:pPr>
             <a:r>
-              <a:rPr lang="en-US" sz="1950" dirty="0" spc="0" kern="0">
+              <a:rPr lang="en-US" sz="1950" dirty="0" spc="-20" kern="0">
                 <a:solidFill>
                   <a:srgbClr val="6B6A66"/>
                 </a:solidFill>
@@ -20342,10 +20375,10 @@
                 <a:ea typeface="Be Vietnam Pro" pitchFamily="34" charset="-122"/>
                 <a:cs typeface="Be Vietnam Pro" pitchFamily="34" charset="-120"/>
               </a:rPr>
-              <a:t>kiểm</a:t>
-            </a:r>
-            <a:r>
-              <a:rPr lang="en-US" sz="1950" dirty="0" spc="-14" kern="0">
+              <a:t>xếp</a:t>
+            </a:r>
+            <a:r>
+              <a:rPr lang="en-US" sz="1950" dirty="0" spc="1" kern="0">
                 <a:solidFill>
                   <a:srgbClr val="6B6A66"/>
                 </a:solidFill>
@@ -20353,10 +20386,10 @@
                 <a:ea typeface="Be Vietnam Pro" pitchFamily="34" charset="-122"/>
                 <a:cs typeface="Be Vietnam Pro" pitchFamily="34" charset="-120"/>
               </a:rPr>
-              <a:t> soát</a:t>
-            </a:r>
-            <a:r>
-              <a:rPr lang="en-US" sz="1950" dirty="0" spc="1" kern="0">
+              <a:t> hàng</a:t>
+            </a:r>
+            <a:r>
+              <a:rPr lang="en-US" sz="1950" dirty="0" spc="-7" kern="0">
                 <a:solidFill>
                   <a:srgbClr val="6B6A66"/>
                 </a:solidFill>
@@ -20364,21 +20397,10 @@
                 <a:ea typeface="Be Vietnam Pro" pitchFamily="34" charset="-122"/>
                 <a:cs typeface="Be Vietnam Pro" pitchFamily="34" charset="-120"/>
               </a:rPr>
-              <a:t> luồng,</a:t>
-            </a:r>
-            <a:r>
-              <a:rPr lang="en-US" sz="1950" dirty="0" spc="-7" kern="0">
-                <a:solidFill>
-                  <a:srgbClr val="6B6A66"/>
-                </a:solidFill>
-                <a:latin typeface="Be Vietnam Pro" pitchFamily="34" charset="0"/>
-                <a:ea typeface="Be Vietnam Pro" pitchFamily="34" charset="-122"/>
-                <a:cs typeface="Be Vietnam Pro" pitchFamily="34" charset="-120"/>
-              </a:rPr>
-              <a:t> máy</a:t>
-            </a:r>
-            <a:r>
-              <a:rPr lang="en-US" sz="1950" dirty="0" spc="34" kern="0">
+              <a:t> gói, máy</a:t>
+            </a:r>
+            <a:r>
+              <a:rPr lang="en-US" sz="1950" dirty="0" spc="33" kern="0">
                 <a:solidFill>
                   <a:srgbClr val="6B6A66"/>
                 </a:solidFill>
@@ -20417,7 +20439,7 @@
               <a:buNone/>
             </a:pPr>
             <a:r>
-              <a:rPr lang="en-US" sz="1950" dirty="0" spc="-11" kern="0">
+              <a:rPr lang="en-US" sz="1950" dirty="0" spc="-9" kern="0">
                 <a:solidFill>
                   <a:srgbClr val="6B6A66"/>
                 </a:solidFill>
@@ -20425,10 +20447,10 @@
                 <a:ea typeface="Be Vietnam Pro" pitchFamily="34" charset="-122"/>
                 <a:cs typeface="Be Vietnam Pro" pitchFamily="34" charset="-120"/>
               </a:rPr>
-              <a:t>lấy</a:t>
-            </a:r>
-            <a:r>
-              <a:rPr lang="en-US" sz="1950" dirty="0" spc="-1" kern="0">
+              <a:t>chạy</a:t>
+            </a:r>
+            <a:r>
+              <a:rPr lang="en-US" sz="1950" dirty="0" spc="-15" kern="0">
                 <a:solidFill>
                   <a:srgbClr val="6B6A66"/>
                 </a:solidFill>
@@ -20436,10 +20458,10 @@
                 <a:ea typeface="Be Vietnam Pro" pitchFamily="34" charset="-122"/>
                 <a:cs typeface="Be Vietnam Pro" pitchFamily="34" charset="-120"/>
               </a:rPr>
-              <a:t> dữ</a:t>
-            </a:r>
-            <a:r>
-              <a:rPr lang="en-US" sz="1950" dirty="0" spc="1" kern="0">
+              <a:t> ngắt</a:t>
+            </a:r>
+            <a:r>
+              <a:rPr lang="en-US" sz="1950" dirty="0" spc="2" kern="0">
                 <a:solidFill>
                   <a:srgbClr val="6B6A66"/>
                 </a:solidFill>
@@ -20447,7 +20469,7 @@
                 <a:ea typeface="Be Vietnam Pro" pitchFamily="34" charset="-122"/>
                 <a:cs typeface="Be Vietnam Pro" pitchFamily="34" charset="-120"/>
               </a:rPr>
-              <a:t> liệu,</a:t>
+              <a:t> mềm,</a:t>
             </a:r>
             <a:r>
               <a:rPr lang="en-US" sz="1950" dirty="0" spc="-8" kern="0">
@@ -22277,17 +22299,6 @@
               </a:rPr>
               <a:t> ngắt</a:t>
             </a:r>
-            <a:r>
-              <a:rPr lang="en-US" sz="2400" b="1" dirty="0" spc="22" kern="0">
-                <a:solidFill>
-                  <a:srgbClr val="14161C"/>
-                </a:solidFill>
-                <a:latin typeface="Be Vietnam Pro" pitchFamily="34" charset="0"/>
-                <a:ea typeface="Be Vietnam Pro" pitchFamily="34" charset="-122"/>
-                <a:cs typeface="Be Vietnam Pro" pitchFamily="34" charset="-120"/>
-              </a:rPr>
-              <a:t> cứng</a:t>
-            </a:r>
             <a:endParaRPr lang="en-US" sz="2400" dirty="0"/>
           </a:p>
           <a:p>
@@ -22484,40 +22495,18 @@
               <a:buNone/>
             </a:pPr>
             <a:r>
-              <a:rPr lang="en-US" sz="2400" b="1" dirty="0" spc="-1" kern="0">
-                <a:solidFill>
-                  <a:srgbClr val="14161C"/>
-                </a:solidFill>
-                <a:latin typeface="Be Vietnam Pro" pitchFamily="34" charset="0"/>
-                <a:ea typeface="Be Vietnam Pro" pitchFamily="34" charset="-122"/>
-                <a:cs typeface="Be Vietnam Pro" pitchFamily="34" charset="-120"/>
-              </a:rPr>
-              <a:t>CPU</a:t>
-            </a:r>
-            <a:r>
-              <a:rPr lang="en-US" sz="2400" b="1" dirty="0" spc="44" kern="0">
-                <a:solidFill>
-                  <a:srgbClr val="14161C"/>
-                </a:solidFill>
-                <a:latin typeface="Be Vietnam Pro" pitchFamily="34" charset="0"/>
-                <a:ea typeface="Be Vietnam Pro" pitchFamily="34" charset="-122"/>
-                <a:cs typeface="Be Vietnam Pro" pitchFamily="34" charset="-120"/>
-              </a:rPr>
-              <a:t> gửi</a:t>
-            </a:r>
-            <a:r>
-              <a:rPr lang="en-US" sz="2400" b="1" dirty="0" spc="-11" kern="0">
-                <a:solidFill>
-                  <a:srgbClr val="14161C"/>
-                </a:solidFill>
-                <a:latin typeface="Be Vietnam Pro" pitchFamily="34" charset="0"/>
-                <a:ea typeface="Be Vietnam Pro" pitchFamily="34" charset="-122"/>
-                <a:cs typeface="Be Vietnam Pro" pitchFamily="34" charset="-120"/>
-              </a:rPr>
-              <a:t> ngắt</a:t>
-            </a:r>
-            <a:r>
-              <a:rPr lang="en-US" sz="2400" b="1" dirty="0" spc="-7" kern="0">
+              <a:rPr lang="en-US" sz="2400" b="1" dirty="0" spc="-14" kern="0">
+                <a:solidFill>
+                  <a:srgbClr val="14161C"/>
+                </a:solidFill>
+                <a:latin typeface="Be Vietnam Pro" pitchFamily="34" charset="0"/>
+                <a:ea typeface="Be Vietnam Pro" pitchFamily="34" charset="-122"/>
+                <a:cs typeface="Be Vietnam Pro" pitchFamily="34" charset="-120"/>
+              </a:rPr>
+              <a:t>Ngắt</a:t>
+            </a:r>
+            <a:r>
+              <a:rPr lang="en-US" sz="2400" b="1" dirty="0" spc="-8" kern="0">
                 <a:solidFill>
                   <a:srgbClr val="14161C"/>
                 </a:solidFill>
@@ -22528,6 +22517,17 @@
               <a:t> mềm</a:t>
             </a:r>
             <a:r>
+              <a:rPr lang="en-US" sz="2400" b="1" dirty="0" spc="-9" kern="0">
+                <a:solidFill>
+                  <a:srgbClr val="14161C"/>
+                </a:solidFill>
+                <a:latin typeface="Be Vietnam Pro" pitchFamily="34" charset="0"/>
+                <a:ea typeface="Be Vietnam Pro" pitchFamily="34" charset="-122"/>
+                <a:cs typeface="Be Vietnam Pro" pitchFamily="34" charset="-120"/>
+              </a:rPr>
+              <a:t> chạy</a:t>
+            </a:r>
+            <a:r>
               <a:rPr lang="en-US" sz="2400" b="1" dirty="0" spc="-4" kern="0">
                 <a:solidFill>
                   <a:srgbClr val="14161C"/>
@@ -22536,18 +22536,29 @@
                 <a:ea typeface="Be Vietnam Pro" pitchFamily="34" charset="-122"/>
                 <a:cs typeface="Be Vietnam Pro" pitchFamily="34" charset="-120"/>
               </a:rPr>
-              <a:t> cho</a:t>
-            </a:r>
-            <a:r>
-              <a:rPr lang="en-US" sz="2400" b="1" dirty="0" spc="-16" kern="0">
-                <a:solidFill>
-                  <a:srgbClr val="14161C"/>
-                </a:solidFill>
-                <a:latin typeface="Be Vietnam Pro" pitchFamily="34" charset="0"/>
-                <a:ea typeface="Be Vietnam Pro" pitchFamily="34" charset="-122"/>
-                <a:cs typeface="Be Vietnam Pro" pitchFamily="34" charset="-120"/>
-              </a:rPr>
-              <a:t> ksoftirqd</a:t>
+              <a:t> việc</a:t>
+            </a:r>
+            <a:r>
+              <a:rPr lang="en-US" sz="2400" b="1" dirty="0" spc="-2" kern="0">
+                <a:solidFill>
+                  <a:srgbClr val="14161C"/>
+                </a:solidFill>
+                <a:latin typeface="Be Vietnam Pro" pitchFamily="34" charset="0"/>
+                <a:ea typeface="Be Vietnam Pro" pitchFamily="34" charset="-122"/>
+                <a:cs typeface="Be Vietnam Pro" pitchFamily="34" charset="-120"/>
+              </a:rPr>
+              <a:t> nhận</a:t>
+            </a:r>
+            <a:r>
+              <a:rPr lang="en-US" sz="2400" b="1" dirty="0" spc="-5" kern="0">
+                <a:solidFill>
+                  <a:srgbClr val="14161C"/>
+                </a:solidFill>
+                <a:latin typeface="Be Vietnam Pro" pitchFamily="34" charset="0"/>
+                <a:ea typeface="Be Vietnam Pro" pitchFamily="34" charset="-122"/>
+                <a:cs typeface="Be Vietnam Pro" pitchFamily="34" charset="-120"/>
+              </a:rPr>
+              <a:t> gói</a:t>
             </a:r>
             <a:endParaRPr lang="en-US" sz="2400" dirty="0"/>
           </a:p>
@@ -22556,39 +22567,6 @@
               <a:buNone/>
             </a:pPr>
             <a:r>
-              <a:rPr lang="en-US" sz="2100" dirty="0" spc="-17" kern="0">
-                <a:solidFill>
-                  <a:srgbClr val="14161C"/>
-                </a:solidFill>
-                <a:latin typeface="Be Vietnam Pro" pitchFamily="34" charset="0"/>
-                <a:ea typeface="Be Vietnam Pro" pitchFamily="34" charset="-122"/>
-                <a:cs typeface="Be Vietnam Pro" pitchFamily="34" charset="-120"/>
-              </a:rPr>
-              <a:t>ksoftirqd</a:t>
-            </a:r>
-            <a:r>
-              <a:rPr lang="en-US" sz="2100" dirty="0" spc="-11" kern="0">
-                <a:solidFill>
-                  <a:srgbClr val="14161C"/>
-                </a:solidFill>
-                <a:latin typeface="Be Vietnam Pro" pitchFamily="34" charset="0"/>
-                <a:ea typeface="Be Vietnam Pro" pitchFamily="34" charset="-122"/>
-                <a:cs typeface="Be Vietnam Pro" pitchFamily="34" charset="-120"/>
-              </a:rPr>
-              <a:t> lấy</a:t>
-            </a:r>
-            <a:r>
-              <a:rPr lang="en-US" sz="2100" dirty="0" spc="-2" kern="0">
-                <a:solidFill>
-                  <a:srgbClr val="14161C"/>
-                </a:solidFill>
-                <a:latin typeface="Be Vietnam Pro" pitchFamily="34" charset="0"/>
-                <a:ea typeface="Be Vietnam Pro" pitchFamily="34" charset="-122"/>
-                <a:cs typeface="Be Vietnam Pro" pitchFamily="34" charset="-120"/>
-              </a:rPr>
-              <a:t> dữ</a:t>
-            </a:r>
-            <a:r>
               <a:rPr lang="en-US" sz="2100" dirty="0" spc="1" kern="0">
                 <a:solidFill>
                   <a:srgbClr val="14161C"/>
@@ -22597,7 +22575,62 @@
                 <a:ea typeface="Be Vietnam Pro" pitchFamily="34" charset="-122"/>
                 <a:cs typeface="Be Vietnam Pro" pitchFamily="34" charset="-120"/>
               </a:rPr>
-              <a:t> liệu</a:t>
+              <a:t>Do</a:t>
+            </a:r>
+            <a:r>
+              <a:rPr lang="en-US" sz="2100" dirty="0" spc="-14" kern="0">
+                <a:solidFill>
+                  <a:srgbClr val="14161C"/>
+                </a:solidFill>
+                <a:latin typeface="Be Vietnam Pro" pitchFamily="34" charset="0"/>
+                <a:ea typeface="Be Vietnam Pro" pitchFamily="34" charset="-122"/>
+                <a:cs typeface="Be Vietnam Pro" pitchFamily="34" charset="-120"/>
+              </a:rPr>
+              <a:t> ksoftirqd,</a:t>
+            </a:r>
+            <a:r>
+              <a:rPr lang="en-US" sz="2100" dirty="0" spc="0" kern="0">
+                <a:solidFill>
+                  <a:srgbClr val="14161C"/>
+                </a:solidFill>
+                <a:latin typeface="Be Vietnam Pro" pitchFamily="34" charset="0"/>
+                <a:ea typeface="Be Vietnam Pro" pitchFamily="34" charset="-122"/>
+                <a:cs typeface="Be Vietnam Pro" pitchFamily="34" charset="-120"/>
+              </a:rPr>
+              <a:t> nếu</a:t>
+            </a:r>
+            <a:r>
+              <a:rPr lang="en-US" sz="2100" dirty="0" spc="-7" kern="0">
+                <a:solidFill>
+                  <a:srgbClr val="14161C"/>
+                </a:solidFill>
+                <a:latin typeface="Be Vietnam Pro" pitchFamily="34" charset="0"/>
+                <a:ea typeface="Be Vietnam Pro" pitchFamily="34" charset="-122"/>
+                <a:cs typeface="Be Vietnam Pro" pitchFamily="34" charset="-120"/>
+              </a:rPr>
+              <a:t> báo</a:t>
+            </a:r>
+            <a:r>
+              <a:rPr lang="en-US" sz="2100" dirty="0" spc="-9" kern="0">
+                <a:solidFill>
+                  <a:srgbClr val="14161C"/>
+                </a:solidFill>
+                <a:latin typeface="Be Vietnam Pro" pitchFamily="34" charset="0"/>
+                <a:ea typeface="Be Vietnam Pro" pitchFamily="34" charset="-122"/>
+                <a:cs typeface="Be Vietnam Pro" pitchFamily="34" charset="-120"/>
+              </a:rPr>
+              <a:t> ngoài</a:t>
+            </a:r>
+            <a:r>
+              <a:rPr lang="en-US" sz="2100" dirty="0" spc="1" kern="0">
+                <a:solidFill>
+                  <a:srgbClr val="14161C"/>
+                </a:solidFill>
+                <a:latin typeface="Be Vietnam Pro" pitchFamily="34" charset="0"/>
+                <a:ea typeface="Be Vietnam Pro" pitchFamily="34" charset="-122"/>
+                <a:cs typeface="Be Vietnam Pro" pitchFamily="34" charset="-120"/>
+              </a:rPr>
+              <a:t> ngữ</a:t>
             </a:r>
             <a:r>
               <a:rPr lang="en-US" sz="2100" dirty="0" spc="-1" kern="0">
@@ -22608,40 +22641,18 @@
                 <a:ea typeface="Be Vietnam Pro" pitchFamily="34" charset="-122"/>
                 <a:cs typeface="Be Vietnam Pro" pitchFamily="34" charset="-120"/>
               </a:rPr>
-              <a:t> từ</a:t>
-            </a:r>
-            <a:r>
-              <a:rPr lang="en-US" sz="2100" dirty="0" spc="-9" kern="0">
-                <a:solidFill>
-                  <a:srgbClr val="14161C"/>
-                </a:solidFill>
-                <a:latin typeface="Be Vietnam Pro" pitchFamily="34" charset="0"/>
-                <a:ea typeface="Be Vietnam Pro" pitchFamily="34" charset="-122"/>
-                <a:cs typeface="Be Vietnam Pro" pitchFamily="34" charset="-120"/>
-              </a:rPr>
-              <a:t> bộ</a:t>
-            </a:r>
-            <a:r>
-              <a:rPr lang="en-US" sz="2100" dirty="0" spc="11" kern="0">
-                <a:solidFill>
-                  <a:srgbClr val="14161C"/>
-                </a:solidFill>
-                <a:latin typeface="Be Vietnam Pro" pitchFamily="34" charset="0"/>
-                <a:ea typeface="Be Vietnam Pro" pitchFamily="34" charset="-122"/>
-                <a:cs typeface="Be Vietnam Pro" pitchFamily="34" charset="-120"/>
-              </a:rPr>
-              <a:t> đệm</a:t>
-            </a:r>
-            <a:r>
-              <a:rPr lang="en-US" sz="2100" dirty="0" spc="-9" kern="0">
-                <a:solidFill>
-                  <a:srgbClr val="14161C"/>
-                </a:solidFill>
-                <a:latin typeface="Be Vietnam Pro" pitchFamily="34" charset="0"/>
-                <a:ea typeface="Be Vietnam Pro" pitchFamily="34" charset="-122"/>
-                <a:cs typeface="Be Vietnam Pro" pitchFamily="34" charset="-120"/>
-              </a:rPr>
-              <a:t> vòng.</a:t>
+              <a:t> cảnh</a:t>
+            </a:r>
+            <a:r>
+              <a:rPr lang="en-US" sz="2100" dirty="0" spc="-15" kern="0">
+                <a:solidFill>
+                  <a:srgbClr val="14161C"/>
+                </a:solidFill>
+                <a:latin typeface="Be Vietnam Pro" pitchFamily="34" charset="0"/>
+                <a:ea typeface="Be Vietnam Pro" pitchFamily="34" charset="-122"/>
+                <a:cs typeface="Be Vietnam Pro" pitchFamily="34" charset="-120"/>
+              </a:rPr>
+              <a:t> ngắt.</a:t>
             </a:r>
             <a:endParaRPr lang="en-US" sz="2400" dirty="0"/>
           </a:p>

</xml_diff>